<commit_message>
Update PBL-3 poster to clean A3 landscape without logos and individual student Gohel Ridham Manojkumar (240170107121)
</commit_message>
<xml_diff>
--- a/pbl3_poster/Hyperparameter_Tuning_PBL3_Presentation.pptx
+++ b/pbl3_poster/Hyperparameter_Tuning_PBL3_Presentation.pptx
@@ -3142,64 +3142,16 @@
           </a:p>
         </p:txBody>
       </p:sp>
-      <p:pic>
-        <p:nvPicPr>
-          <p:cNvPr id="3" name="Picture 2" descr="vgec_logo.png"/>
-          <p:cNvPicPr>
-            <a:picLocks noChangeAspect="1"/>
-          </p:cNvPicPr>
-          <p:nvPr/>
-        </p:nvPicPr>
-        <p:blipFill>
-          <a:blip r:embed="rId2"/>
-          <a:stretch>
-            <a:fillRect/>
-          </a:stretch>
-        </p:blipFill>
-        <p:spPr>
-          <a:xfrm>
-            <a:off x="914400" y="731520"/>
-            <a:ext cx="1097280" cy="1097280"/>
-          </a:xfrm>
-          <a:prstGeom prst="rect">
-            <a:avLst/>
-          </a:prstGeom>
-        </p:spPr>
-      </p:pic>
-      <p:pic>
-        <p:nvPicPr>
-          <p:cNvPr id="4" name="Picture 3" descr="gtu_logo.png"/>
-          <p:cNvPicPr>
-            <a:picLocks noChangeAspect="1"/>
-          </p:cNvPicPr>
-          <p:nvPr/>
-        </p:nvPicPr>
-        <p:blipFill>
-          <a:blip r:embed="rId3"/>
-          <a:stretch>
-            <a:fillRect/>
-          </a:stretch>
-        </p:blipFill>
-        <p:spPr>
-          <a:xfrm>
-            <a:off x="10149840" y="731520"/>
-            <a:ext cx="1082278" cy="1097280"/>
-          </a:xfrm>
-          <a:prstGeom prst="rect">
-            <a:avLst/>
-          </a:prstGeom>
-        </p:spPr>
-      </p:pic>
-      <p:sp>
-        <p:nvSpPr>
-          <p:cNvPr id="5" name="TextBox 4"/>
+      <p:sp>
+        <p:nvSpPr>
+          <p:cNvPr id="3" name="TextBox 2"/>
           <p:cNvSpPr txBox="1"/>
           <p:nvPr/>
         </p:nvSpPr>
         <p:spPr>
           <a:xfrm>
-            <a:off x="2286000" y="777240"/>
-            <a:ext cx="7619695" cy="1005840"/>
+            <a:off x="548640" y="685800"/>
+            <a:ext cx="11094415" cy="1097280"/>
           </a:xfrm>
           <a:prstGeom prst="rect">
             <a:avLst/>
@@ -3213,7 +3165,7 @@
           <a:lstStyle/>
           <a:p>
             <a:pPr algn="ctr">
-              <a:defRPr sz="1500" b="1">
+              <a:defRPr sz="1600" b="1">
                 <a:solidFill>
                   <a:srgbClr val="93C5FD"/>
                 </a:solidFill>
@@ -3225,7 +3177,7 @@
           </a:p>
           <a:p>
             <a:pPr algn="ctr">
-              <a:defRPr sz="1200">
+              <a:defRPr sz="1250">
                 <a:solidFill>
                   <a:srgbClr val="E2E8F0"/>
                 </a:solidFill>
@@ -3239,14 +3191,14 @@
       </p:sp>
       <p:sp>
         <p:nvSpPr>
-          <p:cNvPr id="6" name="Rounded Rectangle 5"/>
+          <p:cNvPr id="4" name="Rounded Rectangle 3"/>
           <p:cNvSpPr/>
           <p:nvPr/>
         </p:nvSpPr>
         <p:spPr>
           <a:xfrm>
-            <a:off x="1097280" y="2011680"/>
-            <a:ext cx="9997135" cy="2286000"/>
+            <a:off x="1097280" y="1920240"/>
+            <a:ext cx="9997135" cy="2194560"/>
           </a:xfrm>
           <a:prstGeom prst="roundRect">
             <a:avLst/>
@@ -3286,7 +3238,7 @@
               </a:defRPr>
             </a:pPr>
             <a:r>
-              <a:t>PBL TASK – 3 ACTIVITY PRESENTATION</a:t>
+              <a:t>PBL TASK – 3 ACTIVITY PRESENTATION (INDIVIDUAL)</a:t>
             </a:r>
           </a:p>
           <a:p>
@@ -3317,14 +3269,14 @@
       </p:sp>
       <p:sp>
         <p:nvSpPr>
-          <p:cNvPr id="7" name="Rounded Rectangle 6"/>
+          <p:cNvPr id="5" name="Rounded Rectangle 4"/>
           <p:cNvSpPr/>
           <p:nvPr/>
         </p:nvSpPr>
         <p:spPr>
           <a:xfrm>
-            <a:off x="1097280" y="4480560"/>
-            <a:ext cx="9997135" cy="1828800"/>
+            <a:off x="1371600" y="4389120"/>
+            <a:ext cx="9448495" cy="1737360"/>
           </a:xfrm>
           <a:prstGeom prst="roundRect">
             <a:avLst/>
@@ -3364,31 +3316,31 @@
               </a:defRPr>
             </a:pPr>
             <a:r>
-              <a:t>SUBMITTED BY:</a:t>
+              <a:t>PREPARED &amp; SUBMITTED BY:</a:t>
             </a:r>
           </a:p>
           <a:p>
             <a:pPr algn="ctr">
-              <a:defRPr sz="1300" b="1">
+              <a:defRPr sz="1600" b="1">
                 <a:solidFill>
                   <a:srgbClr val="FFFFFF"/>
                 </a:solidFill>
               </a:defRPr>
             </a:pPr>
             <a:r>
-              <a:t>Gohel Ridham Manojkumar — Enrollment No.: 240170107121</a:t>
+              <a:t>Gohel Ridham Manojkumar</a:t>
             </a:r>
           </a:p>
           <a:p>
             <a:pPr algn="ctr">
-              <a:defRPr sz="1300" b="1">
-                <a:solidFill>
-                  <a:srgbClr val="FFFFFF"/>
-                </a:solidFill>
-              </a:defRPr>
-            </a:pPr>
-            <a:r>
-              <a:t>Prajapati Vaidik Shaileshbhai — Enrollment No.: 240170107116</a:t>
+              <a:defRPr sz="1200" b="1">
+                <a:solidFill>
+                  <a:srgbClr val="93C5FD"/>
+                </a:solidFill>
+              </a:defRPr>
+            </a:pPr>
+            <a:r>
+              <a:t>Enrollment Number: 240170107121 | Department of Computer Engineering</a:t>
             </a:r>
           </a:p>
           <a:p>
@@ -3400,7 +3352,7 @@
               </a:defRPr>
             </a:pPr>
             <a:r>
-              <a:t>Under the Guidance of: Prof. Niyati Shah | Subject: Data Mining Techniques (BE05000181) | Semester V (2026–27)</a:t>
+              <a:t>Under the Guidance of: Prof. Niyati Shah | Subject: Data Mining Techniques (BE05000181) | Sem V (2026–27)</a:t>
             </a:r>
           </a:p>
         </p:txBody>

</xml_diff>